<commit_message>
Remove outdated WB screenshots from PPT source.
</commit_message>
<xml_diff>
--- a/source/en/getting_started/InVEST_UserGuide_graphics.pptx
+++ b/source/en/getting_started/InVEST_UserGuide_graphics.pptx
@@ -10,11 +10,6 @@
     <p:sldId id="268" r:id="rId4"/>
     <p:sldId id="263" r:id="rId5"/>
     <p:sldId id="264" r:id="rId6"/>
-    <p:sldId id="260" r:id="rId7"/>
-    <p:sldId id="256" r:id="rId8"/>
-    <p:sldId id="259" r:id="rId9"/>
-    <p:sldId id="257" r:id="rId10"/>
-    <p:sldId id="258" r:id="rId11"/>
   </p:sldIdLst>
   <p:sldSz cx="12192000" cy="6858000"/>
   <p:notesSz cx="6858000" cy="9144000"/>
@@ -268,7 +263,7 @@
           <a:p>
             <a:fld id="{A4570EBC-7125-4B5E-B99D-E465C94DD824}" type="datetimeFigureOut">
               <a:rPr lang="en-US" smtClean="0"/>
-              <a:t>6/17/2025</a:t>
+              <a:t>6/16/26</a:t>
             </a:fld>
             <a:endParaRPr lang="en-US"/>
           </a:p>
@@ -466,7 +461,7 @@
           <a:p>
             <a:fld id="{A4570EBC-7125-4B5E-B99D-E465C94DD824}" type="datetimeFigureOut">
               <a:rPr lang="en-US" smtClean="0"/>
-              <a:t>6/17/2025</a:t>
+              <a:t>6/16/26</a:t>
             </a:fld>
             <a:endParaRPr lang="en-US"/>
           </a:p>
@@ -674,7 +669,7 @@
           <a:p>
             <a:fld id="{A4570EBC-7125-4B5E-B99D-E465C94DD824}" type="datetimeFigureOut">
               <a:rPr lang="en-US" smtClean="0"/>
-              <a:t>6/17/2025</a:t>
+              <a:t>6/16/26</a:t>
             </a:fld>
             <a:endParaRPr lang="en-US"/>
           </a:p>
@@ -872,7 +867,7 @@
           <a:p>
             <a:fld id="{A4570EBC-7125-4B5E-B99D-E465C94DD824}" type="datetimeFigureOut">
               <a:rPr lang="en-US" smtClean="0"/>
-              <a:t>6/17/2025</a:t>
+              <a:t>6/16/26</a:t>
             </a:fld>
             <a:endParaRPr lang="en-US"/>
           </a:p>
@@ -1147,7 +1142,7 @@
           <a:p>
             <a:fld id="{A4570EBC-7125-4B5E-B99D-E465C94DD824}" type="datetimeFigureOut">
               <a:rPr lang="en-US" smtClean="0"/>
-              <a:t>6/17/2025</a:t>
+              <a:t>6/16/26</a:t>
             </a:fld>
             <a:endParaRPr lang="en-US"/>
           </a:p>
@@ -1412,7 +1407,7 @@
           <a:p>
             <a:fld id="{A4570EBC-7125-4B5E-B99D-E465C94DD824}" type="datetimeFigureOut">
               <a:rPr lang="en-US" smtClean="0"/>
-              <a:t>6/17/2025</a:t>
+              <a:t>6/16/26</a:t>
             </a:fld>
             <a:endParaRPr lang="en-US"/>
           </a:p>
@@ -1824,7 +1819,7 @@
           <a:p>
             <a:fld id="{A4570EBC-7125-4B5E-B99D-E465C94DD824}" type="datetimeFigureOut">
               <a:rPr lang="en-US" smtClean="0"/>
-              <a:t>6/17/2025</a:t>
+              <a:t>6/16/26</a:t>
             </a:fld>
             <a:endParaRPr lang="en-US"/>
           </a:p>
@@ -1965,7 +1960,7 @@
           <a:p>
             <a:fld id="{A4570EBC-7125-4B5E-B99D-E465C94DD824}" type="datetimeFigureOut">
               <a:rPr lang="en-US" smtClean="0"/>
-              <a:t>6/17/2025</a:t>
+              <a:t>6/16/26</a:t>
             </a:fld>
             <a:endParaRPr lang="en-US"/>
           </a:p>
@@ -2078,7 +2073,7 @@
           <a:p>
             <a:fld id="{A4570EBC-7125-4B5E-B99D-E465C94DD824}" type="datetimeFigureOut">
               <a:rPr lang="en-US" smtClean="0"/>
-              <a:t>6/17/2025</a:t>
+              <a:t>6/16/26</a:t>
             </a:fld>
             <a:endParaRPr lang="en-US"/>
           </a:p>
@@ -2389,7 +2384,7 @@
           <a:p>
             <a:fld id="{A4570EBC-7125-4B5E-B99D-E465C94DD824}" type="datetimeFigureOut">
               <a:rPr lang="en-US" smtClean="0"/>
-              <a:t>6/17/2025</a:t>
+              <a:t>6/16/26</a:t>
             </a:fld>
             <a:endParaRPr lang="en-US"/>
           </a:p>
@@ -2677,7 +2672,7 @@
           <a:p>
             <a:fld id="{A4570EBC-7125-4B5E-B99D-E465C94DD824}" type="datetimeFigureOut">
               <a:rPr lang="en-US" smtClean="0"/>
-              <a:t>6/17/2025</a:t>
+              <a:t>6/16/26</a:t>
             </a:fld>
             <a:endParaRPr lang="en-US"/>
           </a:p>
@@ -2918,7 +2913,7 @@
           <a:p>
             <a:fld id="{A4570EBC-7125-4B5E-B99D-E465C94DD824}" type="datetimeFigureOut">
               <a:rPr lang="en-US" smtClean="0"/>
-              <a:t>6/17/2025</a:t>
+              <a:t>6/16/26</a:t>
             </a:fld>
             <a:endParaRPr lang="en-US"/>
           </a:p>
@@ -3363,17 +3358,21 @@
           <a:lstStyle/>
           <a:p>
             <a:r>
-              <a:rPr lang="en-US"/>
-              <a:t>InVEST 3.16</a:t>
+              <a:rPr lang="en-US" dirty="0" err="1"/>
+              <a:t>InVEST</a:t>
+            </a:r>
+            <a:r>
+              <a:rPr lang="en-US" dirty="0"/>
+              <a:t> 3.16</a:t>
             </a:r>
             <a:br>
-              <a:rPr lang="en-US"/>
+              <a:rPr lang="en-US" dirty="0"/>
             </a:br>
             <a:r>
-              <a:rPr lang="en-US" sz="4800"/>
-              <a:t>(new settings bar)</a:t>
-            </a:r>
-            <a:endParaRPr lang="en-US"/>
+              <a:rPr lang="en-US" sz="4800" dirty="0"/>
+              <a:t>(new settings button)</a:t>
+            </a:r>
+            <a:endParaRPr lang="en-US" dirty="0"/>
           </a:p>
         </p:txBody>
       </p:sp>
@@ -3381,404 +3380,6 @@
     <p:extLst>
       <p:ext uri="{BB962C8B-B14F-4D97-AF65-F5344CB8AC3E}">
         <p14:creationId xmlns:p14="http://schemas.microsoft.com/office/powerpoint/2010/main" val="1978021841"/>
-      </p:ext>
-    </p:extLst>
-  </p:cSld>
-  <p:clrMapOvr>
-    <a:masterClrMapping/>
-  </p:clrMapOvr>
-</p:sld>
-</file>
-
-<file path=ppt/slides/slide10.xml><?xml version="1.0" encoding="utf-8"?>
-<p:sld xmlns:a="http://schemas.openxmlformats.org/drawingml/2006/main" xmlns:r="http://schemas.openxmlformats.org/officeDocument/2006/relationships" xmlns:p="http://schemas.openxmlformats.org/presentationml/2006/main">
-  <p:cSld>
-    <p:spTree>
-      <p:nvGrpSpPr>
-        <p:cNvPr id="1" name=""/>
-        <p:cNvGrpSpPr/>
-        <p:nvPr/>
-      </p:nvGrpSpPr>
-      <p:grpSpPr>
-        <a:xfrm>
-          <a:off x="0" y="0"/>
-          <a:ext cx="0" cy="0"/>
-          <a:chOff x="0" y="0"/>
-          <a:chExt cx="0" cy="0"/>
-        </a:xfrm>
-      </p:grpSpPr>
-      <p:pic>
-        <p:nvPicPr>
-          <p:cNvPr id="3" name="Picture 2">
-            <a:extLst>
-              <a:ext uri="{FF2B5EF4-FFF2-40B4-BE49-F238E27FC236}">
-                <a16:creationId xmlns:a16="http://schemas.microsoft.com/office/drawing/2014/main" id="{A385944C-64A2-3A34-B15E-A32D6BEE4DE2}"/>
-              </a:ext>
-            </a:extLst>
-          </p:cNvPr>
-          <p:cNvPicPr>
-            <a:picLocks noChangeAspect="1"/>
-          </p:cNvPicPr>
-          <p:nvPr/>
-        </p:nvPicPr>
-        <p:blipFill>
-          <a:blip r:embed="rId2"/>
-          <a:stretch>
-            <a:fillRect/>
-          </a:stretch>
-        </p:blipFill>
-        <p:spPr>
-          <a:xfrm>
-            <a:off x="2111234" y="1266614"/>
-            <a:ext cx="9598854" cy="5477256"/>
-          </a:xfrm>
-          <a:prstGeom prst="rect">
-            <a:avLst/>
-          </a:prstGeom>
-        </p:spPr>
-      </p:pic>
-      <p:sp>
-        <p:nvSpPr>
-          <p:cNvPr id="7" name="TextBox 6">
-            <a:extLst>
-              <a:ext uri="{FF2B5EF4-FFF2-40B4-BE49-F238E27FC236}">
-                <a16:creationId xmlns:a16="http://schemas.microsoft.com/office/drawing/2014/main" id="{02DC95A2-E121-41CE-9268-61BA294D4808}"/>
-              </a:ext>
-            </a:extLst>
-          </p:cNvPr>
-          <p:cNvSpPr txBox="1"/>
-          <p:nvPr/>
-        </p:nvSpPr>
-        <p:spPr>
-          <a:xfrm>
-            <a:off x="190836" y="2519393"/>
-            <a:ext cx="1778158" cy="738664"/>
-          </a:xfrm>
-          <a:prstGeom prst="rect">
-            <a:avLst/>
-          </a:prstGeom>
-          <a:noFill/>
-        </p:spPr>
-        <p:txBody>
-          <a:bodyPr wrap="square" rtlCol="0">
-            <a:spAutoFit/>
-          </a:bodyPr>
-          <a:lstStyle/>
-          <a:p>
-            <a:r>
-              <a:rPr lang="en-US" sz="1400" b="1"/>
-              <a:t>Click to view logging messages for this model run </a:t>
-            </a:r>
-          </a:p>
-        </p:txBody>
-      </p:sp>
-      <p:sp>
-        <p:nvSpPr>
-          <p:cNvPr id="8" name="TextBox 7">
-            <a:extLst>
-              <a:ext uri="{FF2B5EF4-FFF2-40B4-BE49-F238E27FC236}">
-                <a16:creationId xmlns:a16="http://schemas.microsoft.com/office/drawing/2014/main" id="{A783F852-105F-259A-E75C-523ED58FA22C}"/>
-              </a:ext>
-            </a:extLst>
-          </p:cNvPr>
-          <p:cNvSpPr txBox="1"/>
-          <p:nvPr/>
-        </p:nvSpPr>
-        <p:spPr>
-          <a:xfrm>
-            <a:off x="7744952" y="392350"/>
-            <a:ext cx="1244636" cy="646331"/>
-          </a:xfrm>
-          <a:prstGeom prst="rect">
-            <a:avLst/>
-          </a:prstGeom>
-          <a:noFill/>
-        </p:spPr>
-        <p:txBody>
-          <a:bodyPr wrap="none" rtlCol="0">
-            <a:spAutoFit/>
-          </a:bodyPr>
-          <a:lstStyle/>
-          <a:p>
-            <a:pPr algn="ctr"/>
-            <a:r>
-              <a:rPr lang="en-US" b="1"/>
-              <a:t>Logging</a:t>
-            </a:r>
-          </a:p>
-          <a:p>
-            <a:pPr algn="ctr"/>
-            <a:r>
-              <a:rPr lang="en-US" b="1"/>
-              <a:t>messages</a:t>
-            </a:r>
-          </a:p>
-        </p:txBody>
-      </p:sp>
-      <p:cxnSp>
-        <p:nvCxnSpPr>
-          <p:cNvPr id="11" name="Straight Arrow Connector 10">
-            <a:extLst>
-              <a:ext uri="{FF2B5EF4-FFF2-40B4-BE49-F238E27FC236}">
-                <a16:creationId xmlns:a16="http://schemas.microsoft.com/office/drawing/2014/main" id="{7F1D104B-3E88-D027-55CD-F6673E9F405D}"/>
-              </a:ext>
-            </a:extLst>
-          </p:cNvPr>
-          <p:cNvCxnSpPr>
-            <a:cxnSpLocks/>
-          </p:cNvCxnSpPr>
-          <p:nvPr/>
-        </p:nvCxnSpPr>
-        <p:spPr>
-          <a:xfrm>
-            <a:off x="1443408" y="2673865"/>
-            <a:ext cx="667826" cy="0"/>
-          </a:xfrm>
-          <a:prstGeom prst="straightConnector1">
-            <a:avLst/>
-          </a:prstGeom>
-          <a:ln w="57150">
-            <a:solidFill>
-              <a:schemeClr val="accent2"/>
-            </a:solidFill>
-            <a:tailEnd type="triangle"/>
-          </a:ln>
-        </p:spPr>
-        <p:style>
-          <a:lnRef idx="2">
-            <a:schemeClr val="accent1"/>
-          </a:lnRef>
-          <a:fillRef idx="0">
-            <a:schemeClr val="accent1"/>
-          </a:fillRef>
-          <a:effectRef idx="1">
-            <a:schemeClr val="accent1"/>
-          </a:effectRef>
-          <a:fontRef idx="minor">
-            <a:schemeClr val="tx1"/>
-          </a:fontRef>
-        </p:style>
-      </p:cxnSp>
-      <p:cxnSp>
-        <p:nvCxnSpPr>
-          <p:cNvPr id="22" name="Straight Arrow Connector 21">
-            <a:extLst>
-              <a:ext uri="{FF2B5EF4-FFF2-40B4-BE49-F238E27FC236}">
-                <a16:creationId xmlns:a16="http://schemas.microsoft.com/office/drawing/2014/main" id="{17E84CD8-F2B9-6592-3E04-2884D007BADF}"/>
-              </a:ext>
-            </a:extLst>
-          </p:cNvPr>
-          <p:cNvCxnSpPr>
-            <a:cxnSpLocks/>
-          </p:cNvCxnSpPr>
-          <p:nvPr/>
-        </p:nvCxnSpPr>
-        <p:spPr>
-          <a:xfrm>
-            <a:off x="8367269" y="1038681"/>
-            <a:ext cx="1" cy="1203292"/>
-          </a:xfrm>
-          <a:prstGeom prst="straightConnector1">
-            <a:avLst/>
-          </a:prstGeom>
-          <a:ln w="76200">
-            <a:solidFill>
-              <a:schemeClr val="accent2"/>
-            </a:solidFill>
-            <a:tailEnd type="triangle"/>
-          </a:ln>
-        </p:spPr>
-        <p:style>
-          <a:lnRef idx="2">
-            <a:schemeClr val="accent1"/>
-          </a:lnRef>
-          <a:fillRef idx="0">
-            <a:schemeClr val="accent1"/>
-          </a:fillRef>
-          <a:effectRef idx="1">
-            <a:schemeClr val="accent1"/>
-          </a:effectRef>
-          <a:fontRef idx="minor">
-            <a:schemeClr val="tx1"/>
-          </a:fontRef>
-        </p:style>
-      </p:cxnSp>
-      <p:sp>
-        <p:nvSpPr>
-          <p:cNvPr id="4" name="TextBox 3">
-            <a:extLst>
-              <a:ext uri="{FF2B5EF4-FFF2-40B4-BE49-F238E27FC236}">
-                <a16:creationId xmlns:a16="http://schemas.microsoft.com/office/drawing/2014/main" id="{E5AE65B7-EF86-E397-6E44-144DF335D314}"/>
-              </a:ext>
-            </a:extLst>
-          </p:cNvPr>
-          <p:cNvSpPr txBox="1"/>
-          <p:nvPr/>
-        </p:nvSpPr>
-        <p:spPr>
-          <a:xfrm>
-            <a:off x="2880445" y="4372709"/>
-            <a:ext cx="1516441" cy="646331"/>
-          </a:xfrm>
-          <a:prstGeom prst="rect">
-            <a:avLst/>
-          </a:prstGeom>
-          <a:noFill/>
-        </p:spPr>
-        <p:txBody>
-          <a:bodyPr wrap="none" rtlCol="0">
-            <a:spAutoFit/>
-          </a:bodyPr>
-          <a:lstStyle/>
-          <a:p>
-            <a:pPr algn="ctr"/>
-            <a:r>
-              <a:rPr lang="en-US" b="1"/>
-              <a:t>Click to view</a:t>
-            </a:r>
-          </a:p>
-          <a:p>
-            <a:pPr algn="ctr"/>
-            <a:r>
-              <a:rPr lang="en-US" b="1"/>
-              <a:t>results</a:t>
-            </a:r>
-          </a:p>
-        </p:txBody>
-      </p:sp>
-      <p:cxnSp>
-        <p:nvCxnSpPr>
-          <p:cNvPr id="10" name="Straight Arrow Connector 9">
-            <a:extLst>
-              <a:ext uri="{FF2B5EF4-FFF2-40B4-BE49-F238E27FC236}">
-                <a16:creationId xmlns:a16="http://schemas.microsoft.com/office/drawing/2014/main" id="{0BA8099E-49B3-BDFD-C2E8-2E62635467DF}"/>
-              </a:ext>
-            </a:extLst>
-          </p:cNvPr>
-          <p:cNvCxnSpPr>
-            <a:cxnSpLocks/>
-          </p:cNvCxnSpPr>
-          <p:nvPr/>
-        </p:nvCxnSpPr>
-        <p:spPr>
-          <a:xfrm>
-            <a:off x="3638666" y="5019040"/>
-            <a:ext cx="0" cy="676887"/>
-          </a:xfrm>
-          <a:prstGeom prst="straightConnector1">
-            <a:avLst/>
-          </a:prstGeom>
-          <a:ln w="76200">
-            <a:solidFill>
-              <a:schemeClr val="accent2"/>
-            </a:solidFill>
-            <a:tailEnd type="triangle"/>
-          </a:ln>
-        </p:spPr>
-        <p:style>
-          <a:lnRef idx="2">
-            <a:schemeClr val="accent1"/>
-          </a:lnRef>
-          <a:fillRef idx="0">
-            <a:schemeClr val="accent1"/>
-          </a:fillRef>
-          <a:effectRef idx="1">
-            <a:schemeClr val="accent1"/>
-          </a:effectRef>
-          <a:fontRef idx="minor">
-            <a:schemeClr val="tx1"/>
-          </a:fontRef>
-        </p:style>
-      </p:cxnSp>
-      <p:sp>
-        <p:nvSpPr>
-          <p:cNvPr id="21" name="TextBox 20">
-            <a:extLst>
-              <a:ext uri="{FF2B5EF4-FFF2-40B4-BE49-F238E27FC236}">
-                <a16:creationId xmlns:a16="http://schemas.microsoft.com/office/drawing/2014/main" id="{527CD429-4E9C-2EDE-9474-2E7D7326E012}"/>
-              </a:ext>
-            </a:extLst>
-          </p:cNvPr>
-          <p:cNvSpPr txBox="1"/>
-          <p:nvPr/>
-        </p:nvSpPr>
-        <p:spPr>
-          <a:xfrm>
-            <a:off x="481912" y="1720342"/>
-            <a:ext cx="1939509" cy="738664"/>
-          </a:xfrm>
-          <a:prstGeom prst="rect">
-            <a:avLst/>
-          </a:prstGeom>
-          <a:noFill/>
-        </p:spPr>
-        <p:txBody>
-          <a:bodyPr wrap="square" rtlCol="0">
-            <a:spAutoFit/>
-          </a:bodyPr>
-          <a:lstStyle/>
-          <a:p>
-            <a:r>
-              <a:rPr lang="en-US" sz="1400" b="1"/>
-              <a:t>Click to return to </a:t>
-            </a:r>
-          </a:p>
-          <a:p>
-            <a:r>
-              <a:rPr lang="en-US" sz="1400" b="1"/>
-              <a:t>the model input screen</a:t>
-            </a:r>
-          </a:p>
-        </p:txBody>
-      </p:sp>
-      <p:cxnSp>
-        <p:nvCxnSpPr>
-          <p:cNvPr id="23" name="Straight Arrow Connector 22">
-            <a:extLst>
-              <a:ext uri="{FF2B5EF4-FFF2-40B4-BE49-F238E27FC236}">
-                <a16:creationId xmlns:a16="http://schemas.microsoft.com/office/drawing/2014/main" id="{9A85BA3A-E3E6-D4A6-B34A-C652731EC4C2}"/>
-              </a:ext>
-            </a:extLst>
-          </p:cNvPr>
-          <p:cNvCxnSpPr>
-            <a:cxnSpLocks/>
-          </p:cNvCxnSpPr>
-          <p:nvPr/>
-        </p:nvCxnSpPr>
-        <p:spPr>
-          <a:xfrm>
-            <a:off x="1443408" y="2320779"/>
-            <a:ext cx="667826" cy="0"/>
-          </a:xfrm>
-          <a:prstGeom prst="straightConnector1">
-            <a:avLst/>
-          </a:prstGeom>
-          <a:ln w="57150">
-            <a:solidFill>
-              <a:schemeClr val="accent2"/>
-            </a:solidFill>
-            <a:tailEnd type="triangle"/>
-          </a:ln>
-        </p:spPr>
-        <p:style>
-          <a:lnRef idx="2">
-            <a:schemeClr val="accent1"/>
-          </a:lnRef>
-          <a:fillRef idx="0">
-            <a:schemeClr val="accent1"/>
-          </a:fillRef>
-          <a:effectRef idx="1">
-            <a:schemeClr val="accent1"/>
-          </a:effectRef>
-          <a:fontRef idx="minor">
-            <a:schemeClr val="tx1"/>
-          </a:fontRef>
-        </p:style>
-      </p:cxnSp>
-    </p:spTree>
-    <p:extLst>
-      <p:ext uri="{BB962C8B-B14F-4D97-AF65-F5344CB8AC3E}">
-        <p14:creationId xmlns:p14="http://schemas.microsoft.com/office/powerpoint/2010/main" val="166539180"/>
       </p:ext>
     </p:extLst>
   </p:cSld>
@@ -6561,1552 +6162,6 @@
     <p:extLst>
       <p:ext uri="{BB962C8B-B14F-4D97-AF65-F5344CB8AC3E}">
         <p14:creationId xmlns:p14="http://schemas.microsoft.com/office/powerpoint/2010/main" val="3542071023"/>
-      </p:ext>
-    </p:extLst>
-  </p:cSld>
-  <p:clrMapOvr>
-    <a:masterClrMapping/>
-  </p:clrMapOvr>
-</p:sld>
-</file>
-
-<file path=ppt/slides/slide6.xml><?xml version="1.0" encoding="utf-8"?>
-<p:sld xmlns:a="http://schemas.openxmlformats.org/drawingml/2006/main" xmlns:r="http://schemas.openxmlformats.org/officeDocument/2006/relationships" xmlns:p="http://schemas.openxmlformats.org/presentationml/2006/main">
-  <p:cSld>
-    <p:spTree>
-      <p:nvGrpSpPr>
-        <p:cNvPr id="1" name=""/>
-        <p:cNvGrpSpPr/>
-        <p:nvPr/>
-      </p:nvGrpSpPr>
-      <p:grpSpPr>
-        <a:xfrm>
-          <a:off x="0" y="0"/>
-          <a:ext cx="0" cy="0"/>
-          <a:chOff x="0" y="0"/>
-          <a:chExt cx="0" cy="0"/>
-        </a:xfrm>
-      </p:grpSpPr>
-      <p:sp>
-        <p:nvSpPr>
-          <p:cNvPr id="2" name="Title 1">
-            <a:extLst>
-              <a:ext uri="{FF2B5EF4-FFF2-40B4-BE49-F238E27FC236}">
-                <a16:creationId xmlns:a16="http://schemas.microsoft.com/office/drawing/2014/main" id="{43AF91B8-5A27-2C29-1BEF-FC7D955BE7F6}"/>
-              </a:ext>
-            </a:extLst>
-          </p:cNvPr>
-          <p:cNvSpPr>
-            <a:spLocks noGrp="1"/>
-          </p:cNvSpPr>
-          <p:nvPr>
-            <p:ph type="ctrTitle"/>
-          </p:nvPr>
-        </p:nvSpPr>
-        <p:spPr/>
-        <p:txBody>
-          <a:bodyPr/>
-          <a:lstStyle/>
-          <a:p>
-            <a:r>
-              <a:rPr lang="en-US"/>
-              <a:t>InVEST pre-3.16</a:t>
-            </a:r>
-          </a:p>
-        </p:txBody>
-      </p:sp>
-    </p:spTree>
-    <p:extLst>
-      <p:ext uri="{BB962C8B-B14F-4D97-AF65-F5344CB8AC3E}">
-        <p14:creationId xmlns:p14="http://schemas.microsoft.com/office/powerpoint/2010/main" val="3081234207"/>
-      </p:ext>
-    </p:extLst>
-  </p:cSld>
-  <p:clrMapOvr>
-    <a:masterClrMapping/>
-  </p:clrMapOvr>
-</p:sld>
-</file>
-
-<file path=ppt/slides/slide7.xml><?xml version="1.0" encoding="utf-8"?>
-<p:sld xmlns:a="http://schemas.openxmlformats.org/drawingml/2006/main" xmlns:r="http://schemas.openxmlformats.org/officeDocument/2006/relationships" xmlns:p="http://schemas.openxmlformats.org/presentationml/2006/main">
-  <p:cSld>
-    <p:spTree>
-      <p:nvGrpSpPr>
-        <p:cNvPr id="1" name=""/>
-        <p:cNvGrpSpPr/>
-        <p:nvPr/>
-      </p:nvGrpSpPr>
-      <p:grpSpPr>
-        <a:xfrm>
-          <a:off x="0" y="0"/>
-          <a:ext cx="0" cy="0"/>
-          <a:chOff x="0" y="0"/>
-          <a:chExt cx="0" cy="0"/>
-        </a:xfrm>
-      </p:grpSpPr>
-      <p:pic>
-        <p:nvPicPr>
-          <p:cNvPr id="5" name="Picture 4">
-            <a:extLst>
-              <a:ext uri="{FF2B5EF4-FFF2-40B4-BE49-F238E27FC236}">
-                <a16:creationId xmlns:a16="http://schemas.microsoft.com/office/drawing/2014/main" id="{1FAFF845-3623-3B72-E2B4-BB9FABA01FFA}"/>
-              </a:ext>
-            </a:extLst>
-          </p:cNvPr>
-          <p:cNvPicPr>
-            <a:picLocks noChangeAspect="1"/>
-          </p:cNvPicPr>
-          <p:nvPr/>
-        </p:nvPicPr>
-        <p:blipFill>
-          <a:blip r:embed="rId2"/>
-          <a:stretch>
-            <a:fillRect/>
-          </a:stretch>
-        </p:blipFill>
-        <p:spPr>
-          <a:xfrm>
-            <a:off x="1535502" y="1282035"/>
-            <a:ext cx="9462210" cy="5481073"/>
-          </a:xfrm>
-          <a:prstGeom prst="rect">
-            <a:avLst/>
-          </a:prstGeom>
-        </p:spPr>
-      </p:pic>
-      <p:sp>
-        <p:nvSpPr>
-          <p:cNvPr id="6" name="TextBox 5">
-            <a:extLst>
-              <a:ext uri="{FF2B5EF4-FFF2-40B4-BE49-F238E27FC236}">
-                <a16:creationId xmlns:a16="http://schemas.microsoft.com/office/drawing/2014/main" id="{BD3DD0F5-4ED4-B11B-76A7-BFF45055FC3A}"/>
-              </a:ext>
-            </a:extLst>
-          </p:cNvPr>
-          <p:cNvSpPr txBox="1"/>
-          <p:nvPr/>
-        </p:nvSpPr>
-        <p:spPr>
-          <a:xfrm>
-            <a:off x="3198649" y="669349"/>
-            <a:ext cx="1746953" cy="369332"/>
-          </a:xfrm>
-          <a:prstGeom prst="rect">
-            <a:avLst/>
-          </a:prstGeom>
-          <a:noFill/>
-        </p:spPr>
-        <p:txBody>
-          <a:bodyPr wrap="none" rtlCol="0">
-            <a:spAutoFit/>
-          </a:bodyPr>
-          <a:lstStyle/>
-          <a:p>
-            <a:r>
-              <a:rPr lang="en-US" b="1"/>
-              <a:t>InVEST models</a:t>
-            </a:r>
-          </a:p>
-        </p:txBody>
-      </p:sp>
-      <p:sp>
-        <p:nvSpPr>
-          <p:cNvPr id="7" name="TextBox 6">
-            <a:extLst>
-              <a:ext uri="{FF2B5EF4-FFF2-40B4-BE49-F238E27FC236}">
-                <a16:creationId xmlns:a16="http://schemas.microsoft.com/office/drawing/2014/main" id="{02DC95A2-E121-41CE-9268-61BA294D4808}"/>
-              </a:ext>
-            </a:extLst>
-          </p:cNvPr>
-          <p:cNvSpPr txBox="1"/>
-          <p:nvPr/>
-        </p:nvSpPr>
-        <p:spPr>
-          <a:xfrm>
-            <a:off x="1687902" y="392351"/>
-            <a:ext cx="901850" cy="646331"/>
-          </a:xfrm>
-          <a:prstGeom prst="rect">
-            <a:avLst/>
-          </a:prstGeom>
-          <a:noFill/>
-        </p:spPr>
-        <p:txBody>
-          <a:bodyPr wrap="none" rtlCol="0">
-            <a:spAutoFit/>
-          </a:bodyPr>
-          <a:lstStyle/>
-          <a:p>
-            <a:pPr algn="ctr"/>
-            <a:r>
-              <a:rPr lang="en-US" b="1"/>
-              <a:t>Home</a:t>
-            </a:r>
-          </a:p>
-          <a:p>
-            <a:pPr algn="ctr"/>
-            <a:r>
-              <a:rPr lang="en-US" b="1"/>
-              <a:t>screen</a:t>
-            </a:r>
-          </a:p>
-        </p:txBody>
-      </p:sp>
-      <p:sp>
-        <p:nvSpPr>
-          <p:cNvPr id="8" name="TextBox 7">
-            <a:extLst>
-              <a:ext uri="{FF2B5EF4-FFF2-40B4-BE49-F238E27FC236}">
-                <a16:creationId xmlns:a16="http://schemas.microsoft.com/office/drawing/2014/main" id="{A783F852-105F-259A-E75C-523ED58FA22C}"/>
-              </a:ext>
-            </a:extLst>
-          </p:cNvPr>
-          <p:cNvSpPr txBox="1"/>
-          <p:nvPr/>
-        </p:nvSpPr>
-        <p:spPr>
-          <a:xfrm>
-            <a:off x="7105291" y="392350"/>
-            <a:ext cx="1372492" cy="646331"/>
-          </a:xfrm>
-          <a:prstGeom prst="rect">
-            <a:avLst/>
-          </a:prstGeom>
-          <a:noFill/>
-        </p:spPr>
-        <p:txBody>
-          <a:bodyPr wrap="none" rtlCol="0">
-            <a:spAutoFit/>
-          </a:bodyPr>
-          <a:lstStyle/>
-          <a:p>
-            <a:pPr algn="ctr"/>
-            <a:r>
-              <a:rPr lang="en-US" b="1"/>
-              <a:t>Previous </a:t>
-            </a:r>
-          </a:p>
-          <a:p>
-            <a:pPr algn="ctr"/>
-            <a:r>
-              <a:rPr lang="en-US" b="1"/>
-              <a:t>model runs</a:t>
-            </a:r>
-          </a:p>
-        </p:txBody>
-      </p:sp>
-      <p:sp>
-        <p:nvSpPr>
-          <p:cNvPr id="9" name="TextBox 8">
-            <a:extLst>
-              <a:ext uri="{FF2B5EF4-FFF2-40B4-BE49-F238E27FC236}">
-                <a16:creationId xmlns:a16="http://schemas.microsoft.com/office/drawing/2014/main" id="{A42F9C0B-24CB-877D-E4EF-EDBDEC941542}"/>
-              </a:ext>
-            </a:extLst>
-          </p:cNvPr>
-          <p:cNvSpPr txBox="1"/>
-          <p:nvPr/>
-        </p:nvSpPr>
-        <p:spPr>
-          <a:xfrm>
-            <a:off x="10032101" y="392350"/>
-            <a:ext cx="1500539" cy="646331"/>
-          </a:xfrm>
-          <a:prstGeom prst="rect">
-            <a:avLst/>
-          </a:prstGeom>
-          <a:noFill/>
-        </p:spPr>
-        <p:txBody>
-          <a:bodyPr wrap="none" rtlCol="0">
-            <a:spAutoFit/>
-          </a:bodyPr>
-          <a:lstStyle/>
-          <a:p>
-            <a:pPr algn="ctr"/>
-            <a:r>
-              <a:rPr lang="en-US" b="1"/>
-              <a:t>Settings/</a:t>
-            </a:r>
-          </a:p>
-          <a:p>
-            <a:pPr algn="ctr"/>
-            <a:r>
-              <a:rPr lang="en-US" b="1"/>
-              <a:t>Sample data</a:t>
-            </a:r>
-          </a:p>
-        </p:txBody>
-      </p:sp>
-      <p:cxnSp>
-        <p:nvCxnSpPr>
-          <p:cNvPr id="11" name="Straight Arrow Connector 10">
-            <a:extLst>
-              <a:ext uri="{FF2B5EF4-FFF2-40B4-BE49-F238E27FC236}">
-                <a16:creationId xmlns:a16="http://schemas.microsoft.com/office/drawing/2014/main" id="{7F1D104B-3E88-D027-55CD-F6673E9F405D}"/>
-              </a:ext>
-            </a:extLst>
-          </p:cNvPr>
-          <p:cNvCxnSpPr>
-            <a:cxnSpLocks/>
-            <a:stCxn id="7" idx="2"/>
-          </p:cNvCxnSpPr>
-          <p:nvPr/>
-        </p:nvCxnSpPr>
-        <p:spPr>
-          <a:xfrm>
-            <a:off x="2138827" y="1038682"/>
-            <a:ext cx="0" cy="669348"/>
-          </a:xfrm>
-          <a:prstGeom prst="straightConnector1">
-            <a:avLst/>
-          </a:prstGeom>
-          <a:ln w="76200">
-            <a:solidFill>
-              <a:schemeClr val="accent2"/>
-            </a:solidFill>
-            <a:tailEnd type="triangle"/>
-          </a:ln>
-        </p:spPr>
-        <p:style>
-          <a:lnRef idx="2">
-            <a:schemeClr val="accent1"/>
-          </a:lnRef>
-          <a:fillRef idx="0">
-            <a:schemeClr val="accent1"/>
-          </a:fillRef>
-          <a:effectRef idx="1">
-            <a:schemeClr val="accent1"/>
-          </a:effectRef>
-          <a:fontRef idx="minor">
-            <a:schemeClr val="tx1"/>
-          </a:fontRef>
-        </p:style>
-      </p:cxnSp>
-      <p:sp>
-        <p:nvSpPr>
-          <p:cNvPr id="15" name="Rectangle 14">
-            <a:extLst>
-              <a:ext uri="{FF2B5EF4-FFF2-40B4-BE49-F238E27FC236}">
-                <a16:creationId xmlns:a16="http://schemas.microsoft.com/office/drawing/2014/main" id="{538CE5C5-269B-DD1A-93F0-1E15E06AC1DD}"/>
-              </a:ext>
-            </a:extLst>
-          </p:cNvPr>
-          <p:cNvSpPr/>
-          <p:nvPr/>
-        </p:nvSpPr>
-        <p:spPr>
-          <a:xfrm>
-            <a:off x="1535502" y="1708030"/>
-            <a:ext cx="1224951" cy="405442"/>
-          </a:xfrm>
-          <a:prstGeom prst="rect">
-            <a:avLst/>
-          </a:prstGeom>
-          <a:noFill/>
-          <a:ln w="57150">
-            <a:solidFill>
-              <a:schemeClr val="accent2"/>
-            </a:solidFill>
-          </a:ln>
-        </p:spPr>
-        <p:style>
-          <a:lnRef idx="2">
-            <a:schemeClr val="accent1">
-              <a:shade val="15000"/>
-            </a:schemeClr>
-          </a:lnRef>
-          <a:fillRef idx="1">
-            <a:schemeClr val="accent1"/>
-          </a:fillRef>
-          <a:effectRef idx="0">
-            <a:schemeClr val="accent1"/>
-          </a:effectRef>
-          <a:fontRef idx="minor">
-            <a:schemeClr val="lt1"/>
-          </a:fontRef>
-        </p:style>
-        <p:txBody>
-          <a:bodyPr rtlCol="0" anchor="ctr"/>
-          <a:lstStyle/>
-          <a:p>
-            <a:pPr algn="ctr"/>
-            <a:endParaRPr lang="en-US"/>
-          </a:p>
-        </p:txBody>
-      </p:sp>
-      <p:cxnSp>
-        <p:nvCxnSpPr>
-          <p:cNvPr id="16" name="Straight Arrow Connector 15">
-            <a:extLst>
-              <a:ext uri="{FF2B5EF4-FFF2-40B4-BE49-F238E27FC236}">
-                <a16:creationId xmlns:a16="http://schemas.microsoft.com/office/drawing/2014/main" id="{7AE5E757-F375-5291-6EAD-24A1F9AC78C1}"/>
-              </a:ext>
-            </a:extLst>
-          </p:cNvPr>
-          <p:cNvCxnSpPr>
-            <a:cxnSpLocks/>
-          </p:cNvCxnSpPr>
-          <p:nvPr/>
-        </p:nvCxnSpPr>
-        <p:spPr>
-          <a:xfrm flipH="1">
-            <a:off x="3193077" y="1038682"/>
-            <a:ext cx="642278" cy="1273197"/>
-          </a:xfrm>
-          <a:prstGeom prst="straightConnector1">
-            <a:avLst/>
-          </a:prstGeom>
-          <a:ln w="76200">
-            <a:solidFill>
-              <a:schemeClr val="accent2"/>
-            </a:solidFill>
-            <a:tailEnd type="triangle"/>
-          </a:ln>
-        </p:spPr>
-        <p:style>
-          <a:lnRef idx="2">
-            <a:schemeClr val="accent1"/>
-          </a:lnRef>
-          <a:fillRef idx="0">
-            <a:schemeClr val="accent1"/>
-          </a:fillRef>
-          <a:effectRef idx="1">
-            <a:schemeClr val="accent1"/>
-          </a:effectRef>
-          <a:fontRef idx="minor">
-            <a:schemeClr val="tx1"/>
-          </a:fontRef>
-        </p:style>
-      </p:cxnSp>
-      <p:cxnSp>
-        <p:nvCxnSpPr>
-          <p:cNvPr id="18" name="Straight Arrow Connector 17">
-            <a:extLst>
-              <a:ext uri="{FF2B5EF4-FFF2-40B4-BE49-F238E27FC236}">
-                <a16:creationId xmlns:a16="http://schemas.microsoft.com/office/drawing/2014/main" id="{88F48D4D-E95A-76AF-CB24-E43FF18E2D00}"/>
-              </a:ext>
-            </a:extLst>
-          </p:cNvPr>
-          <p:cNvCxnSpPr>
-            <a:cxnSpLocks/>
-          </p:cNvCxnSpPr>
-          <p:nvPr/>
-        </p:nvCxnSpPr>
-        <p:spPr>
-          <a:xfrm>
-            <a:off x="4301181" y="1038681"/>
-            <a:ext cx="644421" cy="1273198"/>
-          </a:xfrm>
-          <a:prstGeom prst="straightConnector1">
-            <a:avLst/>
-          </a:prstGeom>
-          <a:ln w="76200">
-            <a:solidFill>
-              <a:schemeClr val="accent2"/>
-            </a:solidFill>
-            <a:tailEnd type="triangle"/>
-          </a:ln>
-        </p:spPr>
-        <p:style>
-          <a:lnRef idx="2">
-            <a:schemeClr val="accent1"/>
-          </a:lnRef>
-          <a:fillRef idx="0">
-            <a:schemeClr val="accent1"/>
-          </a:fillRef>
-          <a:effectRef idx="1">
-            <a:schemeClr val="accent1"/>
-          </a:effectRef>
-          <a:fontRef idx="minor">
-            <a:schemeClr val="tx1"/>
-          </a:fontRef>
-        </p:style>
-      </p:cxnSp>
-      <p:cxnSp>
-        <p:nvCxnSpPr>
-          <p:cNvPr id="22" name="Straight Arrow Connector 21">
-            <a:extLst>
-              <a:ext uri="{FF2B5EF4-FFF2-40B4-BE49-F238E27FC236}">
-                <a16:creationId xmlns:a16="http://schemas.microsoft.com/office/drawing/2014/main" id="{17E84CD8-F2B9-6592-3E04-2884D007BADF}"/>
-              </a:ext>
-            </a:extLst>
-          </p:cNvPr>
-          <p:cNvCxnSpPr>
-            <a:cxnSpLocks/>
-          </p:cNvCxnSpPr>
-          <p:nvPr/>
-        </p:nvCxnSpPr>
-        <p:spPr>
-          <a:xfrm>
-            <a:off x="7791537" y="1038681"/>
-            <a:ext cx="0" cy="1135176"/>
-          </a:xfrm>
-          <a:prstGeom prst="straightConnector1">
-            <a:avLst/>
-          </a:prstGeom>
-          <a:ln w="76200">
-            <a:solidFill>
-              <a:schemeClr val="accent2"/>
-            </a:solidFill>
-            <a:tailEnd type="triangle"/>
-          </a:ln>
-        </p:spPr>
-        <p:style>
-          <a:lnRef idx="2">
-            <a:schemeClr val="accent1"/>
-          </a:lnRef>
-          <a:fillRef idx="0">
-            <a:schemeClr val="accent1"/>
-          </a:fillRef>
-          <a:effectRef idx="1">
-            <a:schemeClr val="accent1"/>
-          </a:effectRef>
-          <a:fontRef idx="minor">
-            <a:schemeClr val="tx1"/>
-          </a:fontRef>
-        </p:style>
-      </p:cxnSp>
-      <p:cxnSp>
-        <p:nvCxnSpPr>
-          <p:cNvPr id="24" name="Straight Arrow Connector 23">
-            <a:extLst>
-              <a:ext uri="{FF2B5EF4-FFF2-40B4-BE49-F238E27FC236}">
-                <a16:creationId xmlns:a16="http://schemas.microsoft.com/office/drawing/2014/main" id="{3F7D70D8-0CC7-93F8-73F8-4679AA18F256}"/>
-              </a:ext>
-            </a:extLst>
-          </p:cNvPr>
-          <p:cNvCxnSpPr>
-            <a:cxnSpLocks/>
-          </p:cNvCxnSpPr>
-          <p:nvPr/>
-        </p:nvCxnSpPr>
-        <p:spPr>
-          <a:xfrm>
-            <a:off x="10782370" y="1038681"/>
-            <a:ext cx="0" cy="669349"/>
-          </a:xfrm>
-          <a:prstGeom prst="straightConnector1">
-            <a:avLst/>
-          </a:prstGeom>
-          <a:ln w="76200">
-            <a:solidFill>
-              <a:schemeClr val="accent2"/>
-            </a:solidFill>
-            <a:tailEnd type="triangle"/>
-          </a:ln>
-        </p:spPr>
-        <p:style>
-          <a:lnRef idx="2">
-            <a:schemeClr val="accent1"/>
-          </a:lnRef>
-          <a:fillRef idx="0">
-            <a:schemeClr val="accent1"/>
-          </a:fillRef>
-          <a:effectRef idx="1">
-            <a:schemeClr val="accent1"/>
-          </a:effectRef>
-          <a:fontRef idx="minor">
-            <a:schemeClr val="tx1"/>
-          </a:fontRef>
-        </p:style>
-      </p:cxnSp>
-      <p:sp>
-        <p:nvSpPr>
-          <p:cNvPr id="26" name="Rectangle 25">
-            <a:extLst>
-              <a:ext uri="{FF2B5EF4-FFF2-40B4-BE49-F238E27FC236}">
-                <a16:creationId xmlns:a16="http://schemas.microsoft.com/office/drawing/2014/main" id="{20D925C7-EC38-EEFF-E0D2-D8595EC629A4}"/>
-              </a:ext>
-            </a:extLst>
-          </p:cNvPr>
-          <p:cNvSpPr/>
-          <p:nvPr/>
-        </p:nvSpPr>
-        <p:spPr>
-          <a:xfrm>
-            <a:off x="10575985" y="1731352"/>
-            <a:ext cx="421728" cy="382120"/>
-          </a:xfrm>
-          <a:prstGeom prst="rect">
-            <a:avLst/>
-          </a:prstGeom>
-          <a:noFill/>
-          <a:ln w="57150">
-            <a:solidFill>
-              <a:schemeClr val="accent2"/>
-            </a:solidFill>
-          </a:ln>
-        </p:spPr>
-        <p:style>
-          <a:lnRef idx="2">
-            <a:schemeClr val="accent1">
-              <a:shade val="15000"/>
-            </a:schemeClr>
-          </a:lnRef>
-          <a:fillRef idx="1">
-            <a:schemeClr val="accent1"/>
-          </a:fillRef>
-          <a:effectRef idx="0">
-            <a:schemeClr val="accent1"/>
-          </a:effectRef>
-          <a:fontRef idx="minor">
-            <a:schemeClr val="lt1"/>
-          </a:fontRef>
-        </p:style>
-        <p:txBody>
-          <a:bodyPr rtlCol="0" anchor="ctr"/>
-          <a:lstStyle/>
-          <a:p>
-            <a:pPr algn="ctr"/>
-            <a:endParaRPr lang="en-US"/>
-          </a:p>
-        </p:txBody>
-      </p:sp>
-    </p:spTree>
-    <p:extLst>
-      <p:ext uri="{BB962C8B-B14F-4D97-AF65-F5344CB8AC3E}">
-        <p14:creationId xmlns:p14="http://schemas.microsoft.com/office/powerpoint/2010/main" val="3765661946"/>
-      </p:ext>
-    </p:extLst>
-  </p:cSld>
-  <p:clrMapOvr>
-    <a:masterClrMapping/>
-  </p:clrMapOvr>
-</p:sld>
-</file>
-
-<file path=ppt/slides/slide8.xml><?xml version="1.0" encoding="utf-8"?>
-<p:sld xmlns:a="http://schemas.openxmlformats.org/drawingml/2006/main" xmlns:r="http://schemas.openxmlformats.org/officeDocument/2006/relationships" xmlns:p="http://schemas.openxmlformats.org/presentationml/2006/main">
-  <p:cSld>
-    <p:spTree>
-      <p:nvGrpSpPr>
-        <p:cNvPr id="1" name=""/>
-        <p:cNvGrpSpPr/>
-        <p:nvPr/>
-      </p:nvGrpSpPr>
-      <p:grpSpPr>
-        <a:xfrm>
-          <a:off x="0" y="0"/>
-          <a:ext cx="0" cy="0"/>
-          <a:chOff x="0" y="0"/>
-          <a:chExt cx="0" cy="0"/>
-        </a:xfrm>
-      </p:grpSpPr>
-      <p:pic>
-        <p:nvPicPr>
-          <p:cNvPr id="5" name="Picture 4">
-            <a:extLst>
-              <a:ext uri="{FF2B5EF4-FFF2-40B4-BE49-F238E27FC236}">
-                <a16:creationId xmlns:a16="http://schemas.microsoft.com/office/drawing/2014/main" id="{1FAFF845-3623-3B72-E2B4-BB9FABA01FFA}"/>
-              </a:ext>
-            </a:extLst>
-          </p:cNvPr>
-          <p:cNvPicPr>
-            <a:picLocks noChangeAspect="1"/>
-          </p:cNvPicPr>
-          <p:nvPr/>
-        </p:nvPicPr>
-        <p:blipFill>
-          <a:blip r:embed="rId2"/>
-          <a:stretch>
-            <a:fillRect/>
-          </a:stretch>
-        </p:blipFill>
-        <p:spPr>
-          <a:xfrm>
-            <a:off x="1535502" y="1282035"/>
-            <a:ext cx="9462210" cy="5481073"/>
-          </a:xfrm>
-          <a:prstGeom prst="rect">
-            <a:avLst/>
-          </a:prstGeom>
-        </p:spPr>
-      </p:pic>
-      <p:sp>
-        <p:nvSpPr>
-          <p:cNvPr id="9" name="TextBox 8">
-            <a:extLst>
-              <a:ext uri="{FF2B5EF4-FFF2-40B4-BE49-F238E27FC236}">
-                <a16:creationId xmlns:a16="http://schemas.microsoft.com/office/drawing/2014/main" id="{A42F9C0B-24CB-877D-E4EF-EDBDEC941542}"/>
-              </a:ext>
-            </a:extLst>
-          </p:cNvPr>
-          <p:cNvSpPr txBox="1"/>
-          <p:nvPr/>
-        </p:nvSpPr>
-        <p:spPr>
-          <a:xfrm>
-            <a:off x="10032101" y="392350"/>
-            <a:ext cx="1500539" cy="646331"/>
-          </a:xfrm>
-          <a:prstGeom prst="rect">
-            <a:avLst/>
-          </a:prstGeom>
-          <a:noFill/>
-        </p:spPr>
-        <p:txBody>
-          <a:bodyPr wrap="none" rtlCol="0">
-            <a:spAutoFit/>
-          </a:bodyPr>
-          <a:lstStyle/>
-          <a:p>
-            <a:pPr algn="ctr"/>
-            <a:r>
-              <a:rPr lang="en-US" b="1"/>
-              <a:t>Settings/</a:t>
-            </a:r>
-          </a:p>
-          <a:p>
-            <a:pPr algn="ctr"/>
-            <a:r>
-              <a:rPr lang="en-US" b="1"/>
-              <a:t>Sample data</a:t>
-            </a:r>
-          </a:p>
-        </p:txBody>
-      </p:sp>
-      <p:cxnSp>
-        <p:nvCxnSpPr>
-          <p:cNvPr id="24" name="Straight Arrow Connector 23">
-            <a:extLst>
-              <a:ext uri="{FF2B5EF4-FFF2-40B4-BE49-F238E27FC236}">
-                <a16:creationId xmlns:a16="http://schemas.microsoft.com/office/drawing/2014/main" id="{3F7D70D8-0CC7-93F8-73F8-4679AA18F256}"/>
-              </a:ext>
-            </a:extLst>
-          </p:cNvPr>
-          <p:cNvCxnSpPr>
-            <a:cxnSpLocks/>
-          </p:cNvCxnSpPr>
-          <p:nvPr/>
-        </p:nvCxnSpPr>
-        <p:spPr>
-          <a:xfrm>
-            <a:off x="10782370" y="1038681"/>
-            <a:ext cx="0" cy="669349"/>
-          </a:xfrm>
-          <a:prstGeom prst="straightConnector1">
-            <a:avLst/>
-          </a:prstGeom>
-          <a:ln w="76200">
-            <a:solidFill>
-              <a:schemeClr val="accent2"/>
-            </a:solidFill>
-            <a:tailEnd type="triangle"/>
-          </a:ln>
-        </p:spPr>
-        <p:style>
-          <a:lnRef idx="2">
-            <a:schemeClr val="accent1"/>
-          </a:lnRef>
-          <a:fillRef idx="0">
-            <a:schemeClr val="accent1"/>
-          </a:fillRef>
-          <a:effectRef idx="1">
-            <a:schemeClr val="accent1"/>
-          </a:effectRef>
-          <a:fontRef idx="minor">
-            <a:schemeClr val="tx1"/>
-          </a:fontRef>
-        </p:style>
-      </p:cxnSp>
-      <p:sp>
-        <p:nvSpPr>
-          <p:cNvPr id="26" name="Rectangle 25">
-            <a:extLst>
-              <a:ext uri="{FF2B5EF4-FFF2-40B4-BE49-F238E27FC236}">
-                <a16:creationId xmlns:a16="http://schemas.microsoft.com/office/drawing/2014/main" id="{20D925C7-EC38-EEFF-E0D2-D8595EC629A4}"/>
-              </a:ext>
-            </a:extLst>
-          </p:cNvPr>
-          <p:cNvSpPr/>
-          <p:nvPr/>
-        </p:nvSpPr>
-        <p:spPr>
-          <a:xfrm>
-            <a:off x="10575985" y="1717806"/>
-            <a:ext cx="421728" cy="382120"/>
-          </a:xfrm>
-          <a:prstGeom prst="rect">
-            <a:avLst/>
-          </a:prstGeom>
-          <a:noFill/>
-          <a:ln w="76200">
-            <a:solidFill>
-              <a:schemeClr val="accent2"/>
-            </a:solidFill>
-          </a:ln>
-        </p:spPr>
-        <p:style>
-          <a:lnRef idx="2">
-            <a:schemeClr val="accent1">
-              <a:shade val="15000"/>
-            </a:schemeClr>
-          </a:lnRef>
-          <a:fillRef idx="1">
-            <a:schemeClr val="accent1"/>
-          </a:fillRef>
-          <a:effectRef idx="0">
-            <a:schemeClr val="accent1"/>
-          </a:effectRef>
-          <a:fontRef idx="minor">
-            <a:schemeClr val="lt1"/>
-          </a:fontRef>
-        </p:style>
-        <p:txBody>
-          <a:bodyPr rtlCol="0" anchor="ctr"/>
-          <a:lstStyle/>
-          <a:p>
-            <a:pPr algn="ctr"/>
-            <a:endParaRPr lang="en-US"/>
-          </a:p>
-        </p:txBody>
-      </p:sp>
-    </p:spTree>
-    <p:extLst>
-      <p:ext uri="{BB962C8B-B14F-4D97-AF65-F5344CB8AC3E}">
-        <p14:creationId xmlns:p14="http://schemas.microsoft.com/office/powerpoint/2010/main" val="2889747785"/>
-      </p:ext>
-    </p:extLst>
-  </p:cSld>
-  <p:clrMapOvr>
-    <a:masterClrMapping/>
-  </p:clrMapOvr>
-</p:sld>
-</file>
-
-<file path=ppt/slides/slide9.xml><?xml version="1.0" encoding="utf-8"?>
-<p:sld xmlns:a="http://schemas.openxmlformats.org/drawingml/2006/main" xmlns:r="http://schemas.openxmlformats.org/officeDocument/2006/relationships" xmlns:p="http://schemas.openxmlformats.org/presentationml/2006/main">
-  <p:cSld>
-    <p:spTree>
-      <p:nvGrpSpPr>
-        <p:cNvPr id="1" name=""/>
-        <p:cNvGrpSpPr/>
-        <p:nvPr/>
-      </p:nvGrpSpPr>
-      <p:grpSpPr>
-        <a:xfrm>
-          <a:off x="0" y="0"/>
-          <a:ext cx="0" cy="0"/>
-          <a:chOff x="0" y="0"/>
-          <a:chExt cx="0" cy="0"/>
-        </a:xfrm>
-      </p:grpSpPr>
-      <p:pic>
-        <p:nvPicPr>
-          <p:cNvPr id="3" name="Picture 2">
-            <a:extLst>
-              <a:ext uri="{FF2B5EF4-FFF2-40B4-BE49-F238E27FC236}">
-                <a16:creationId xmlns:a16="http://schemas.microsoft.com/office/drawing/2014/main" id="{65DD01FA-74B6-C288-1324-4C1E02DF5FF6}"/>
-              </a:ext>
-            </a:extLst>
-          </p:cNvPr>
-          <p:cNvPicPr>
-            <a:picLocks noChangeAspect="1"/>
-          </p:cNvPicPr>
-          <p:nvPr/>
-        </p:nvPicPr>
-        <p:blipFill>
-          <a:blip r:embed="rId2"/>
-          <a:stretch>
-            <a:fillRect/>
-          </a:stretch>
-        </p:blipFill>
-        <p:spPr>
-          <a:xfrm>
-            <a:off x="2427747" y="1282781"/>
-            <a:ext cx="9598854" cy="5477256"/>
-          </a:xfrm>
-          <a:prstGeom prst="rect">
-            <a:avLst/>
-          </a:prstGeom>
-        </p:spPr>
-      </p:pic>
-      <p:sp>
-        <p:nvSpPr>
-          <p:cNvPr id="7" name="TextBox 6">
-            <a:extLst>
-              <a:ext uri="{FF2B5EF4-FFF2-40B4-BE49-F238E27FC236}">
-                <a16:creationId xmlns:a16="http://schemas.microsoft.com/office/drawing/2014/main" id="{02DC95A2-E121-41CE-9268-61BA294D4808}"/>
-              </a:ext>
-            </a:extLst>
-          </p:cNvPr>
-          <p:cNvSpPr txBox="1"/>
-          <p:nvPr/>
-        </p:nvSpPr>
-        <p:spPr>
-          <a:xfrm>
-            <a:off x="2883226" y="4928888"/>
-            <a:ext cx="1388970" cy="646331"/>
-          </a:xfrm>
-          <a:prstGeom prst="rect">
-            <a:avLst/>
-          </a:prstGeom>
-          <a:noFill/>
-        </p:spPr>
-        <p:txBody>
-          <a:bodyPr wrap="none" rtlCol="0">
-            <a:spAutoFit/>
-          </a:bodyPr>
-          <a:lstStyle/>
-          <a:p>
-            <a:pPr algn="ctr"/>
-            <a:r>
-              <a:rPr lang="en-US" b="1"/>
-              <a:t>Click to run</a:t>
-            </a:r>
-          </a:p>
-          <a:p>
-            <a:pPr algn="ctr"/>
-            <a:r>
-              <a:rPr lang="en-US" b="1"/>
-              <a:t>the model</a:t>
-            </a:r>
-          </a:p>
-        </p:txBody>
-      </p:sp>
-      <p:sp>
-        <p:nvSpPr>
-          <p:cNvPr id="8" name="TextBox 7">
-            <a:extLst>
-              <a:ext uri="{FF2B5EF4-FFF2-40B4-BE49-F238E27FC236}">
-                <a16:creationId xmlns:a16="http://schemas.microsoft.com/office/drawing/2014/main" id="{A783F852-105F-259A-E75C-523ED58FA22C}"/>
-              </a:ext>
-            </a:extLst>
-          </p:cNvPr>
-          <p:cNvSpPr txBox="1"/>
-          <p:nvPr/>
-        </p:nvSpPr>
-        <p:spPr>
-          <a:xfrm>
-            <a:off x="9342180" y="392350"/>
-            <a:ext cx="849592" cy="646331"/>
-          </a:xfrm>
-          <a:prstGeom prst="rect">
-            <a:avLst/>
-          </a:prstGeom>
-          <a:noFill/>
-        </p:spPr>
-        <p:txBody>
-          <a:bodyPr wrap="none" rtlCol="0">
-            <a:spAutoFit/>
-          </a:bodyPr>
-          <a:lstStyle/>
-          <a:p>
-            <a:pPr algn="ctr"/>
-            <a:r>
-              <a:rPr lang="en-US" b="1"/>
-              <a:t>Model</a:t>
-            </a:r>
-          </a:p>
-          <a:p>
-            <a:pPr algn="ctr"/>
-            <a:r>
-              <a:rPr lang="en-US" b="1"/>
-              <a:t>inputs</a:t>
-            </a:r>
-          </a:p>
-        </p:txBody>
-      </p:sp>
-      <p:cxnSp>
-        <p:nvCxnSpPr>
-          <p:cNvPr id="11" name="Straight Arrow Connector 10">
-            <a:extLst>
-              <a:ext uri="{FF2B5EF4-FFF2-40B4-BE49-F238E27FC236}">
-                <a16:creationId xmlns:a16="http://schemas.microsoft.com/office/drawing/2014/main" id="{7F1D104B-3E88-D027-55CD-F6673E9F405D}"/>
-              </a:ext>
-            </a:extLst>
-          </p:cNvPr>
-          <p:cNvCxnSpPr>
-            <a:cxnSpLocks/>
-            <a:stCxn id="7" idx="2"/>
-          </p:cNvCxnSpPr>
-          <p:nvPr/>
-        </p:nvCxnSpPr>
-        <p:spPr>
-          <a:xfrm flipH="1">
-            <a:off x="3577708" y="5575219"/>
-            <a:ext cx="3" cy="669348"/>
-          </a:xfrm>
-          <a:prstGeom prst="straightConnector1">
-            <a:avLst/>
-          </a:prstGeom>
-          <a:ln w="76200">
-            <a:solidFill>
-              <a:schemeClr val="accent2"/>
-            </a:solidFill>
-            <a:tailEnd type="triangle"/>
-          </a:ln>
-        </p:spPr>
-        <p:style>
-          <a:lnRef idx="2">
-            <a:schemeClr val="accent1"/>
-          </a:lnRef>
-          <a:fillRef idx="0">
-            <a:schemeClr val="accent1"/>
-          </a:fillRef>
-          <a:effectRef idx="1">
-            <a:schemeClr val="accent1"/>
-          </a:effectRef>
-          <a:fontRef idx="minor">
-            <a:schemeClr val="tx1"/>
-          </a:fontRef>
-        </p:style>
-      </p:cxnSp>
-      <p:cxnSp>
-        <p:nvCxnSpPr>
-          <p:cNvPr id="22" name="Straight Arrow Connector 21">
-            <a:extLst>
-              <a:ext uri="{FF2B5EF4-FFF2-40B4-BE49-F238E27FC236}">
-                <a16:creationId xmlns:a16="http://schemas.microsoft.com/office/drawing/2014/main" id="{17E84CD8-F2B9-6592-3E04-2884D007BADF}"/>
-              </a:ext>
-            </a:extLst>
-          </p:cNvPr>
-          <p:cNvCxnSpPr>
-            <a:cxnSpLocks/>
-          </p:cNvCxnSpPr>
-          <p:nvPr/>
-        </p:nvCxnSpPr>
-        <p:spPr>
-          <a:xfrm>
-            <a:off x="9766975" y="1121434"/>
-            <a:ext cx="0" cy="992038"/>
-          </a:xfrm>
-          <a:prstGeom prst="straightConnector1">
-            <a:avLst/>
-          </a:prstGeom>
-          <a:ln w="76200">
-            <a:solidFill>
-              <a:schemeClr val="accent2"/>
-            </a:solidFill>
-            <a:tailEnd type="triangle"/>
-          </a:ln>
-        </p:spPr>
-        <p:style>
-          <a:lnRef idx="2">
-            <a:schemeClr val="accent1"/>
-          </a:lnRef>
-          <a:fillRef idx="0">
-            <a:schemeClr val="accent1"/>
-          </a:fillRef>
-          <a:effectRef idx="1">
-            <a:schemeClr val="accent1"/>
-          </a:effectRef>
-          <a:fontRef idx="minor">
-            <a:schemeClr val="tx1"/>
-          </a:fontRef>
-        </p:style>
-      </p:cxnSp>
-      <p:sp>
-        <p:nvSpPr>
-          <p:cNvPr id="10" name="TextBox 9">
-            <a:extLst>
-              <a:ext uri="{FF2B5EF4-FFF2-40B4-BE49-F238E27FC236}">
-                <a16:creationId xmlns:a16="http://schemas.microsoft.com/office/drawing/2014/main" id="{2B221A4D-C108-D289-782E-E236D5D31C8A}"/>
-              </a:ext>
-            </a:extLst>
-          </p:cNvPr>
-          <p:cNvSpPr txBox="1"/>
-          <p:nvPr/>
-        </p:nvSpPr>
-        <p:spPr>
-          <a:xfrm>
-            <a:off x="6011099" y="392350"/>
-            <a:ext cx="1935209" cy="646331"/>
-          </a:xfrm>
-          <a:prstGeom prst="rect">
-            <a:avLst/>
-          </a:prstGeom>
-          <a:noFill/>
-        </p:spPr>
-        <p:txBody>
-          <a:bodyPr wrap="none" rtlCol="0">
-            <a:spAutoFit/>
-          </a:bodyPr>
-          <a:lstStyle/>
-          <a:p>
-            <a:pPr algn="ctr"/>
-            <a:r>
-              <a:rPr lang="en-US" b="1"/>
-              <a:t>Tabs for multiple</a:t>
-            </a:r>
-          </a:p>
-          <a:p>
-            <a:pPr algn="ctr"/>
-            <a:r>
-              <a:rPr lang="en-US" b="1"/>
-              <a:t>model runs</a:t>
-            </a:r>
-          </a:p>
-        </p:txBody>
-      </p:sp>
-      <p:cxnSp>
-        <p:nvCxnSpPr>
-          <p:cNvPr id="12" name="Straight Arrow Connector 11">
-            <a:extLst>
-              <a:ext uri="{FF2B5EF4-FFF2-40B4-BE49-F238E27FC236}">
-                <a16:creationId xmlns:a16="http://schemas.microsoft.com/office/drawing/2014/main" id="{E260D4AF-D4BC-2E10-4C25-5B5B40CD30ED}"/>
-              </a:ext>
-            </a:extLst>
-          </p:cNvPr>
-          <p:cNvCxnSpPr>
-            <a:cxnSpLocks/>
-          </p:cNvCxnSpPr>
-          <p:nvPr/>
-        </p:nvCxnSpPr>
-        <p:spPr>
-          <a:xfrm flipH="1">
-            <a:off x="6349242" y="1038681"/>
-            <a:ext cx="319119" cy="669349"/>
-          </a:xfrm>
-          <a:prstGeom prst="straightConnector1">
-            <a:avLst/>
-          </a:prstGeom>
-          <a:ln w="76200">
-            <a:solidFill>
-              <a:schemeClr val="accent2"/>
-            </a:solidFill>
-            <a:tailEnd type="triangle"/>
-          </a:ln>
-        </p:spPr>
-        <p:style>
-          <a:lnRef idx="2">
-            <a:schemeClr val="accent1"/>
-          </a:lnRef>
-          <a:fillRef idx="0">
-            <a:schemeClr val="accent1"/>
-          </a:fillRef>
-          <a:effectRef idx="1">
-            <a:schemeClr val="accent1"/>
-          </a:effectRef>
-          <a:fontRef idx="minor">
-            <a:schemeClr val="tx1"/>
-          </a:fontRef>
-        </p:style>
-      </p:cxnSp>
-      <p:cxnSp>
-        <p:nvCxnSpPr>
-          <p:cNvPr id="14" name="Straight Arrow Connector 13">
-            <a:extLst>
-              <a:ext uri="{FF2B5EF4-FFF2-40B4-BE49-F238E27FC236}">
-                <a16:creationId xmlns:a16="http://schemas.microsoft.com/office/drawing/2014/main" id="{AD47D0D4-EB4A-AC92-8053-A249511B7BE0}"/>
-              </a:ext>
-            </a:extLst>
-          </p:cNvPr>
-          <p:cNvCxnSpPr>
-            <a:cxnSpLocks/>
-          </p:cNvCxnSpPr>
-          <p:nvPr/>
-        </p:nvCxnSpPr>
-        <p:spPr>
-          <a:xfrm>
-            <a:off x="7326090" y="1067435"/>
-            <a:ext cx="362519" cy="611840"/>
-          </a:xfrm>
-          <a:prstGeom prst="straightConnector1">
-            <a:avLst/>
-          </a:prstGeom>
-          <a:ln w="76200">
-            <a:solidFill>
-              <a:schemeClr val="accent2"/>
-            </a:solidFill>
-            <a:tailEnd type="triangle"/>
-          </a:ln>
-        </p:spPr>
-        <p:style>
-          <a:lnRef idx="2">
-            <a:schemeClr val="accent1"/>
-          </a:lnRef>
-          <a:fillRef idx="0">
-            <a:schemeClr val="accent1"/>
-          </a:fillRef>
-          <a:effectRef idx="1">
-            <a:schemeClr val="accent1"/>
-          </a:effectRef>
-          <a:fontRef idx="minor">
-            <a:schemeClr val="tx1"/>
-          </a:fontRef>
-        </p:style>
-      </p:cxnSp>
-      <p:sp>
-        <p:nvSpPr>
-          <p:cNvPr id="19" name="Rectangle 18">
-            <a:extLst>
-              <a:ext uri="{FF2B5EF4-FFF2-40B4-BE49-F238E27FC236}">
-                <a16:creationId xmlns:a16="http://schemas.microsoft.com/office/drawing/2014/main" id="{D794A90B-300B-14EB-BFD1-8D3AC13DC45F}"/>
-              </a:ext>
-            </a:extLst>
-          </p:cNvPr>
-          <p:cNvSpPr/>
-          <p:nvPr/>
-        </p:nvSpPr>
-        <p:spPr>
-          <a:xfrm>
-            <a:off x="4712678" y="2119543"/>
-            <a:ext cx="7313920" cy="4640494"/>
-          </a:xfrm>
-          <a:prstGeom prst="rect">
-            <a:avLst/>
-          </a:prstGeom>
-          <a:noFill/>
-          <a:ln w="57150">
-            <a:solidFill>
-              <a:schemeClr val="accent2"/>
-            </a:solidFill>
-          </a:ln>
-        </p:spPr>
-        <p:style>
-          <a:lnRef idx="2">
-            <a:schemeClr val="accent1">
-              <a:shade val="15000"/>
-            </a:schemeClr>
-          </a:lnRef>
-          <a:fillRef idx="1">
-            <a:schemeClr val="accent1"/>
-          </a:fillRef>
-          <a:effectRef idx="0">
-            <a:schemeClr val="accent1"/>
-          </a:effectRef>
-          <a:fontRef idx="minor">
-            <a:schemeClr val="lt1"/>
-          </a:fontRef>
-        </p:style>
-        <p:txBody>
-          <a:bodyPr rtlCol="0" anchor="ctr"/>
-          <a:lstStyle/>
-          <a:p>
-            <a:pPr algn="ctr"/>
-            <a:endParaRPr lang="en-US"/>
-          </a:p>
-        </p:txBody>
-      </p:sp>
-      <p:sp>
-        <p:nvSpPr>
-          <p:cNvPr id="20" name="TextBox 19">
-            <a:extLst>
-              <a:ext uri="{FF2B5EF4-FFF2-40B4-BE49-F238E27FC236}">
-                <a16:creationId xmlns:a16="http://schemas.microsoft.com/office/drawing/2014/main" id="{7F3A21B8-2148-B65A-2DB3-8188AB682A89}"/>
-              </a:ext>
-            </a:extLst>
-          </p:cNvPr>
-          <p:cNvSpPr txBox="1"/>
-          <p:nvPr/>
-        </p:nvSpPr>
-        <p:spPr>
-          <a:xfrm>
-            <a:off x="34377" y="2908721"/>
-            <a:ext cx="2210488" cy="492443"/>
-          </a:xfrm>
-          <a:prstGeom prst="rect">
-            <a:avLst/>
-          </a:prstGeom>
-          <a:noFill/>
-        </p:spPr>
-        <p:txBody>
-          <a:bodyPr wrap="square" rtlCol="0">
-            <a:spAutoFit/>
-          </a:bodyPr>
-          <a:lstStyle/>
-          <a:p>
-            <a:r>
-              <a:rPr lang="en-US" sz="1300" b="1"/>
-              <a:t>Save parameters and optionally data to a file</a:t>
-            </a:r>
-          </a:p>
-        </p:txBody>
-      </p:sp>
-      <p:sp>
-        <p:nvSpPr>
-          <p:cNvPr id="27" name="TextBox 26">
-            <a:extLst>
-              <a:ext uri="{FF2B5EF4-FFF2-40B4-BE49-F238E27FC236}">
-                <a16:creationId xmlns:a16="http://schemas.microsoft.com/office/drawing/2014/main" id="{4322903F-FD9C-5F8A-6466-F36291309C89}"/>
-              </a:ext>
-            </a:extLst>
-          </p:cNvPr>
-          <p:cNvSpPr txBox="1"/>
-          <p:nvPr/>
-        </p:nvSpPr>
-        <p:spPr>
-          <a:xfrm>
-            <a:off x="79931" y="2131766"/>
-            <a:ext cx="2044460" cy="692497"/>
-          </a:xfrm>
-          <a:prstGeom prst="rect">
-            <a:avLst/>
-          </a:prstGeom>
-          <a:noFill/>
-        </p:spPr>
-        <p:txBody>
-          <a:bodyPr wrap="square" rtlCol="0">
-            <a:spAutoFit/>
-          </a:bodyPr>
-          <a:lstStyle/>
-          <a:p>
-            <a:r>
-              <a:rPr lang="en-US" sz="1300" b="1"/>
-              <a:t>Load parameters and optionally data from a saved file</a:t>
-            </a:r>
-          </a:p>
-        </p:txBody>
-      </p:sp>
-      <p:cxnSp>
-        <p:nvCxnSpPr>
-          <p:cNvPr id="28" name="Straight Arrow Connector 27">
-            <a:extLst>
-              <a:ext uri="{FF2B5EF4-FFF2-40B4-BE49-F238E27FC236}">
-                <a16:creationId xmlns:a16="http://schemas.microsoft.com/office/drawing/2014/main" id="{FB79E811-4DAC-A6F5-970A-F0EF96DFBB5D}"/>
-              </a:ext>
-            </a:extLst>
-          </p:cNvPr>
-          <p:cNvCxnSpPr>
-            <a:cxnSpLocks/>
-          </p:cNvCxnSpPr>
-          <p:nvPr/>
-        </p:nvCxnSpPr>
-        <p:spPr>
-          <a:xfrm>
-            <a:off x="1530773" y="2654146"/>
-            <a:ext cx="955040" cy="346441"/>
-          </a:xfrm>
-          <a:prstGeom prst="straightConnector1">
-            <a:avLst/>
-          </a:prstGeom>
-          <a:ln w="57150">
-            <a:solidFill>
-              <a:srgbClr val="996633"/>
-            </a:solidFill>
-            <a:tailEnd type="triangle"/>
-          </a:ln>
-        </p:spPr>
-        <p:style>
-          <a:lnRef idx="2">
-            <a:schemeClr val="accent1"/>
-          </a:lnRef>
-          <a:fillRef idx="0">
-            <a:schemeClr val="accent1"/>
-          </a:fillRef>
-          <a:effectRef idx="1">
-            <a:schemeClr val="accent1"/>
-          </a:effectRef>
-          <a:fontRef idx="minor">
-            <a:schemeClr val="tx1"/>
-          </a:fontRef>
-        </p:style>
-      </p:cxnSp>
-      <p:cxnSp>
-        <p:nvCxnSpPr>
-          <p:cNvPr id="32" name="Straight Arrow Connector 31">
-            <a:extLst>
-              <a:ext uri="{FF2B5EF4-FFF2-40B4-BE49-F238E27FC236}">
-                <a16:creationId xmlns:a16="http://schemas.microsoft.com/office/drawing/2014/main" id="{820959A1-E341-61DE-8A76-08AF2FF93AC5}"/>
-              </a:ext>
-            </a:extLst>
-          </p:cNvPr>
-          <p:cNvCxnSpPr>
-            <a:cxnSpLocks/>
-          </p:cNvCxnSpPr>
-          <p:nvPr/>
-        </p:nvCxnSpPr>
-        <p:spPr>
-          <a:xfrm>
-            <a:off x="1903307" y="3255047"/>
-            <a:ext cx="582506" cy="0"/>
-          </a:xfrm>
-          <a:prstGeom prst="straightConnector1">
-            <a:avLst/>
-          </a:prstGeom>
-          <a:ln w="57150">
-            <a:solidFill>
-              <a:srgbClr val="996633"/>
-            </a:solidFill>
-            <a:tailEnd type="triangle"/>
-          </a:ln>
-        </p:spPr>
-        <p:style>
-          <a:lnRef idx="2">
-            <a:schemeClr val="accent1"/>
-          </a:lnRef>
-          <a:fillRef idx="0">
-            <a:schemeClr val="accent1"/>
-          </a:fillRef>
-          <a:effectRef idx="1">
-            <a:schemeClr val="accent1"/>
-          </a:effectRef>
-          <a:fontRef idx="minor">
-            <a:schemeClr val="tx1"/>
-          </a:fontRef>
-        </p:style>
-      </p:cxnSp>
-      <p:sp>
-        <p:nvSpPr>
-          <p:cNvPr id="35" name="TextBox 34">
-            <a:extLst>
-              <a:ext uri="{FF2B5EF4-FFF2-40B4-BE49-F238E27FC236}">
-                <a16:creationId xmlns:a16="http://schemas.microsoft.com/office/drawing/2014/main" id="{86BD9555-8BC1-C2C7-D76E-5F0947AA30A1}"/>
-              </a:ext>
-            </a:extLst>
-          </p:cNvPr>
-          <p:cNvSpPr txBox="1"/>
-          <p:nvPr/>
-        </p:nvSpPr>
-        <p:spPr>
-          <a:xfrm>
-            <a:off x="34377" y="3479641"/>
-            <a:ext cx="2210485" cy="492443"/>
-          </a:xfrm>
-          <a:prstGeom prst="rect">
-            <a:avLst/>
-          </a:prstGeom>
-          <a:noFill/>
-        </p:spPr>
-        <p:txBody>
-          <a:bodyPr wrap="square" rtlCol="0">
-            <a:spAutoFit/>
-          </a:bodyPr>
-          <a:lstStyle/>
-          <a:p>
-            <a:r>
-              <a:rPr lang="en-US" sz="1300" b="1"/>
-              <a:t>Link to User Guide  </a:t>
-            </a:r>
-          </a:p>
-          <a:p>
-            <a:r>
-              <a:rPr lang="en-US" sz="1300" b="1"/>
-              <a:t>chapter for this model</a:t>
-            </a:r>
-          </a:p>
-        </p:txBody>
-      </p:sp>
-      <p:cxnSp>
-        <p:nvCxnSpPr>
-          <p:cNvPr id="36" name="Straight Arrow Connector 35">
-            <a:extLst>
-              <a:ext uri="{FF2B5EF4-FFF2-40B4-BE49-F238E27FC236}">
-                <a16:creationId xmlns:a16="http://schemas.microsoft.com/office/drawing/2014/main" id="{8F42063D-9A64-0CBA-8B21-D8F3C83D1E58}"/>
-              </a:ext>
-            </a:extLst>
-          </p:cNvPr>
-          <p:cNvCxnSpPr>
-            <a:cxnSpLocks/>
-          </p:cNvCxnSpPr>
-          <p:nvPr/>
-        </p:nvCxnSpPr>
-        <p:spPr>
-          <a:xfrm flipV="1">
-            <a:off x="1686560" y="3549227"/>
-            <a:ext cx="799253" cy="90298"/>
-          </a:xfrm>
-          <a:prstGeom prst="straightConnector1">
-            <a:avLst/>
-          </a:prstGeom>
-          <a:ln w="57150">
-            <a:solidFill>
-              <a:srgbClr val="996633"/>
-            </a:solidFill>
-            <a:tailEnd type="triangle"/>
-          </a:ln>
-        </p:spPr>
-        <p:style>
-          <a:lnRef idx="2">
-            <a:schemeClr val="accent1"/>
-          </a:lnRef>
-          <a:fillRef idx="0">
-            <a:schemeClr val="accent1"/>
-          </a:fillRef>
-          <a:effectRef idx="1">
-            <a:schemeClr val="accent1"/>
-          </a:effectRef>
-          <a:fontRef idx="minor">
-            <a:schemeClr val="tx1"/>
-          </a:fontRef>
-        </p:style>
-      </p:cxnSp>
-      <p:sp>
-        <p:nvSpPr>
-          <p:cNvPr id="37" name="TextBox 36">
-            <a:extLst>
-              <a:ext uri="{FF2B5EF4-FFF2-40B4-BE49-F238E27FC236}">
-                <a16:creationId xmlns:a16="http://schemas.microsoft.com/office/drawing/2014/main" id="{7921C943-524A-5D82-0763-013237043342}"/>
-              </a:ext>
-            </a:extLst>
-          </p:cNvPr>
-          <p:cNvSpPr txBox="1"/>
-          <p:nvPr/>
-        </p:nvSpPr>
-        <p:spPr>
-          <a:xfrm>
-            <a:off x="34377" y="4015368"/>
-            <a:ext cx="2210488" cy="492443"/>
-          </a:xfrm>
-          <a:prstGeom prst="rect">
-            <a:avLst/>
-          </a:prstGeom>
-          <a:noFill/>
-        </p:spPr>
-        <p:txBody>
-          <a:bodyPr wrap="square" rtlCol="0">
-            <a:spAutoFit/>
-          </a:bodyPr>
-          <a:lstStyle/>
-          <a:p>
-            <a:r>
-              <a:rPr lang="en-US" sz="1300" b="1"/>
-              <a:t>Link to Community Forum posts related to this model</a:t>
-            </a:r>
-          </a:p>
-        </p:txBody>
-      </p:sp>
-      <p:cxnSp>
-        <p:nvCxnSpPr>
-          <p:cNvPr id="44" name="Straight Arrow Connector 43">
-            <a:extLst>
-              <a:ext uri="{FF2B5EF4-FFF2-40B4-BE49-F238E27FC236}">
-                <a16:creationId xmlns:a16="http://schemas.microsoft.com/office/drawing/2014/main" id="{FEC082BF-A6D9-6D8C-C1BB-5BF8367B28A6}"/>
-              </a:ext>
-            </a:extLst>
-          </p:cNvPr>
-          <p:cNvCxnSpPr>
-            <a:cxnSpLocks/>
-          </p:cNvCxnSpPr>
-          <p:nvPr/>
-        </p:nvCxnSpPr>
-        <p:spPr>
-          <a:xfrm flipV="1">
-            <a:off x="2090524" y="3929050"/>
-            <a:ext cx="594823" cy="276104"/>
-          </a:xfrm>
-          <a:prstGeom prst="straightConnector1">
-            <a:avLst/>
-          </a:prstGeom>
-          <a:ln w="57150">
-            <a:solidFill>
-              <a:srgbClr val="996633"/>
-            </a:solidFill>
-            <a:tailEnd type="triangle"/>
-          </a:ln>
-        </p:spPr>
-        <p:style>
-          <a:lnRef idx="2">
-            <a:schemeClr val="accent1"/>
-          </a:lnRef>
-          <a:fillRef idx="0">
-            <a:schemeClr val="accent1"/>
-          </a:fillRef>
-          <a:effectRef idx="1">
-            <a:schemeClr val="accent1"/>
-          </a:effectRef>
-          <a:fontRef idx="minor">
-            <a:schemeClr val="tx1"/>
-          </a:fontRef>
-        </p:style>
-      </p:cxnSp>
-    </p:spTree>
-    <p:extLst>
-      <p:ext uri="{BB962C8B-B14F-4D97-AF65-F5344CB8AC3E}">
-        <p14:creationId xmlns:p14="http://schemas.microsoft.com/office/powerpoint/2010/main" val="3238096088"/>
       </p:ext>
     </p:extLst>
   </p:cSld>

</xml_diff>